<commit_message>
docs: update TFM presentation
</commit_message>
<xml_diff>
--- a/outputs/CicloViento-presentacion-proyecto.pptx
+++ b/outputs/CicloViento-presentacion-proyecto.pptx
@@ -2,24 +2,24 @@
 <file path=ppt/presentation.xml><?xml version="1.0" encoding="utf-8"?>
 <p:presentation xmlns:p="http://schemas.openxmlformats.org/presentationml/2006/main">
   <p:sldMasterIdLst>
-    <p:sldMasterId xmlns:r="http://schemas.openxmlformats.org/officeDocument/2006/relationships" id="2147483648" r:id="Rb49d5185f4644a8b"/>
+    <p:sldMasterId xmlns:r="http://schemas.openxmlformats.org/officeDocument/2006/relationships" id="2147483648" r:id="R45f52962ad3d4b3d"/>
   </p:sldMasterIdLst>
   <p:notesMasterIdLst>
-    <p:notesMasterId xmlns:r="http://schemas.openxmlformats.org/officeDocument/2006/relationships" r:id="Rb91c898f78df4cf2"/>
+    <p:notesMasterId xmlns:r="http://schemas.openxmlformats.org/officeDocument/2006/relationships" r:id="R788fc4caaec94070"/>
   </p:notesMasterIdLst>
   <p:sldIdLst>
-    <p:sldId xmlns:r="http://schemas.openxmlformats.org/officeDocument/2006/relationships" id="256" r:id="R5a4a191b081d495f"/>
-    <p:sldId xmlns:r="http://schemas.openxmlformats.org/officeDocument/2006/relationships" id="257" r:id="R60b203cbb24641ce"/>
-    <p:sldId xmlns:r="http://schemas.openxmlformats.org/officeDocument/2006/relationships" id="258" r:id="R178f9a7588ce418b"/>
-    <p:sldId xmlns:r="http://schemas.openxmlformats.org/officeDocument/2006/relationships" id="259" r:id="R0de62dfa4bbe4d0b"/>
-    <p:sldId xmlns:r="http://schemas.openxmlformats.org/officeDocument/2006/relationships" id="260" r:id="R4383e1a6e20c4fff"/>
-    <p:sldId xmlns:r="http://schemas.openxmlformats.org/officeDocument/2006/relationships" id="261" r:id="Rcf0bcaba422547dd"/>
-    <p:sldId xmlns:r="http://schemas.openxmlformats.org/officeDocument/2006/relationships" id="262" r:id="Rbb4e235804494570"/>
-    <p:sldId xmlns:r="http://schemas.openxmlformats.org/officeDocument/2006/relationships" id="263" r:id="Re6944917ba7545e2"/>
-    <p:sldId xmlns:r="http://schemas.openxmlformats.org/officeDocument/2006/relationships" id="264" r:id="Rb55460e6509a4a29"/>
-    <p:sldId xmlns:r="http://schemas.openxmlformats.org/officeDocument/2006/relationships" id="265" r:id="Rd893087800924fc0"/>
-    <p:sldId xmlns:r="http://schemas.openxmlformats.org/officeDocument/2006/relationships" id="266" r:id="R20487ec7b28849df"/>
-    <p:sldId xmlns:r="http://schemas.openxmlformats.org/officeDocument/2006/relationships" id="267" r:id="R6cc55e7ab2c14f7a"/>
+    <p:sldId xmlns:r="http://schemas.openxmlformats.org/officeDocument/2006/relationships" id="256" r:id="R88789e28293d46b5"/>
+    <p:sldId xmlns:r="http://schemas.openxmlformats.org/officeDocument/2006/relationships" id="257" r:id="R72380b0fe3ff45de"/>
+    <p:sldId xmlns:r="http://schemas.openxmlformats.org/officeDocument/2006/relationships" id="258" r:id="R41485bc7c5214b5b"/>
+    <p:sldId xmlns:r="http://schemas.openxmlformats.org/officeDocument/2006/relationships" id="259" r:id="R3684c5112eeb4d6c"/>
+    <p:sldId xmlns:r="http://schemas.openxmlformats.org/officeDocument/2006/relationships" id="260" r:id="R2216ca6a7dfb404e"/>
+    <p:sldId xmlns:r="http://schemas.openxmlformats.org/officeDocument/2006/relationships" id="261" r:id="Rf62e33620df1430e"/>
+    <p:sldId xmlns:r="http://schemas.openxmlformats.org/officeDocument/2006/relationships" id="262" r:id="Re036a762bfc24b57"/>
+    <p:sldId xmlns:r="http://schemas.openxmlformats.org/officeDocument/2006/relationships" id="263" r:id="R1721c40903274b76"/>
+    <p:sldId xmlns:r="http://schemas.openxmlformats.org/officeDocument/2006/relationships" id="264" r:id="Rbd964b45bde54b9f"/>
+    <p:sldId xmlns:r="http://schemas.openxmlformats.org/officeDocument/2006/relationships" id="265" r:id="R7d17bfa19be247d7"/>
+    <p:sldId xmlns:r="http://schemas.openxmlformats.org/officeDocument/2006/relationships" id="266" r:id="R1db8f10db8454488"/>
+    <p:sldId xmlns:r="http://schemas.openxmlformats.org/officeDocument/2006/relationships" id="267" r:id="R7a02ee6bd64e4834"/>
   </p:sldIdLst>
   <p:sldSz cx="12192000" cy="6858000"/>
   <p:notesSz cx="6858000" cy="9144000"/>
@@ -1243,7 +1243,7 @@
   </p:cSld>
   <p:clrMap bg1="lt1" tx1="dk1" bg2="lt2" tx2="dk2" accent1="accent1" accent2="accent2" accent3="accent3" accent4="accent4" accent5="accent5" accent6="accent6" hlink="hlink" folHlink="folHlink"/>
   <p:sldLayoutIdLst>
-    <p:sldLayoutId xmlns:r="http://schemas.openxmlformats.org/officeDocument/2006/relationships" id="2147483649" r:id="R6c5f17eea3244ae4"/>
+    <p:sldLayoutId xmlns:r="http://schemas.openxmlformats.org/officeDocument/2006/relationships" id="2147483649" r:id="R9a360dce2b8b4101"/>
   </p:sldLayoutIdLst>
   <p:txStyles>
     <p:titleStyle>
@@ -1824,6 +1824,7 @@
           <a:lstStyle xmlns:a="http://schemas.openxmlformats.org/drawingml/2006/main"/>
           <a:p xmlns:a="http://schemas.openxmlformats.org/drawingml/2006/main">
             <a:pPr algn="l">
+              <a:buNone/>
               <a:defRPr sz="1050" b="1">
                 <a:solidFill>
                   <a:srgbClr val="3D8DFF"/>
@@ -1882,6 +1883,7 @@
           <a:lstStyle xmlns:a="http://schemas.openxmlformats.org/drawingml/2006/main"/>
           <a:p xmlns:a="http://schemas.openxmlformats.org/drawingml/2006/main">
             <a:pPr algn="l">
+              <a:buNone/>
               <a:defRPr sz="4650" b="1">
                 <a:solidFill>
                   <a:srgbClr val="0B1B2B"/>
@@ -1940,6 +1942,7 @@
           <a:lstStyle xmlns:a="http://schemas.openxmlformats.org/drawingml/2006/main"/>
           <a:p xmlns:a="http://schemas.openxmlformats.org/drawingml/2006/main">
             <a:pPr algn="l">
+              <a:buNone/>
               <a:defRPr sz="2025" b="0">
                 <a:solidFill>
                   <a:srgbClr val="536273"/>
@@ -2029,6 +2032,7 @@
           <a:lstStyle xmlns:a="http://schemas.openxmlformats.org/drawingml/2006/main"/>
           <a:p xmlns:a="http://schemas.openxmlformats.org/drawingml/2006/main">
             <a:pPr algn="l">
+              <a:buNone/>
               <a:defRPr sz="1350" b="1">
                 <a:solidFill>
                   <a:srgbClr val="0B1B2B"/>
@@ -2087,6 +2091,7 @@
           <a:lstStyle xmlns:a="http://schemas.openxmlformats.org/drawingml/2006/main"/>
           <a:p xmlns:a="http://schemas.openxmlformats.org/drawingml/2006/main">
             <a:pPr algn="l">
+              <a:buNone/>
               <a:defRPr sz="1500" b="1">
                 <a:solidFill>
                   <a:srgbClr val="0B1B2B"/>
@@ -2112,14 +2117,14 @@
       </p:sp>
       <p:pic>
         <p:nvPicPr>
-          <p:cNvPr id="15" name=""/>
+          <p:cNvPr id="17" name=""/>
           <p:cNvPicPr>
             <a:picLocks xmlns:a="http://schemas.openxmlformats.org/drawingml/2006/main" noChangeAspect="1"/>
           </p:cNvPicPr>
           <p:nvPr/>
         </p:nvPicPr>
         <p:blipFill>
-          <a:blip xmlns:r="http://schemas.openxmlformats.org/officeDocument/2006/relationships" xmlns:a="http://schemas.openxmlformats.org/drawingml/2006/main" r:embed="R56ca59e5b63440dc"/>
+          <a:blip xmlns:r="http://schemas.openxmlformats.org/officeDocument/2006/relationships" xmlns:a="http://schemas.openxmlformats.org/drawingml/2006/main" r:embed="Rc6e64ee3da474289"/>
           <a:srcRect xmlns:a="http://schemas.openxmlformats.org/drawingml/2006/main" l="0" t="316" r="0" b="316"/>
           <a:stretch xmlns:a="http://schemas.openxmlformats.org/drawingml/2006/main">
             <a:fillRect l="0" t="0" r="0" b="0"/>
@@ -2172,6 +2177,7 @@
           <a:lstStyle xmlns:a="http://schemas.openxmlformats.org/drawingml/2006/main"/>
           <a:p xmlns:a="http://schemas.openxmlformats.org/drawingml/2006/main">
             <a:pPr algn="l">
+              <a:buNone/>
               <a:defRPr sz="1050" b="0">
                 <a:solidFill>
                   <a:srgbClr val="536273"/>
@@ -2252,6 +2258,7 @@
           <a:lstStyle xmlns:a="http://schemas.openxmlformats.org/drawingml/2006/main"/>
           <a:p xmlns:a="http://schemas.openxmlformats.org/drawingml/2006/main">
             <a:pPr algn="l">
+              <a:buNone/>
               <a:defRPr sz="1050" b="1">
                 <a:solidFill>
                   <a:srgbClr val="3D8DFF"/>
@@ -2310,6 +2317,7 @@
           <a:lstStyle xmlns:a="http://schemas.openxmlformats.org/drawingml/2006/main"/>
           <a:p xmlns:a="http://schemas.openxmlformats.org/drawingml/2006/main">
             <a:pPr algn="l">
+              <a:buNone/>
               <a:defRPr sz="2850" b="1">
                 <a:solidFill>
                   <a:srgbClr val="0B1B2B"/>
@@ -2430,6 +2438,7 @@
           <a:lstStyle xmlns:a="http://schemas.openxmlformats.org/drawingml/2006/main"/>
           <a:p xmlns:a="http://schemas.openxmlformats.org/drawingml/2006/main">
             <a:pPr algn="l">
+              <a:buNone/>
               <a:defRPr sz="975" b="0">
                 <a:solidFill>
                   <a:srgbClr val="536273"/>
@@ -2488,6 +2497,7 @@
           <a:lstStyle xmlns:a="http://schemas.openxmlformats.org/drawingml/2006/main"/>
           <a:p xmlns:a="http://schemas.openxmlformats.org/drawingml/2006/main">
             <a:pPr algn="r">
+              <a:buNone/>
               <a:defRPr sz="975" b="0">
                 <a:solidFill>
                   <a:srgbClr val="536273"/>
@@ -2612,6 +2622,7 @@
           <a:lstStyle xmlns:a="http://schemas.openxmlformats.org/drawingml/2006/main"/>
           <a:p xmlns:a="http://schemas.openxmlformats.org/drawingml/2006/main">
             <a:pPr algn="l">
+              <a:buNone/>
               <a:defRPr sz="1800" b="1">
                 <a:solidFill>
                   <a:srgbClr val="0B1B2B"/>
@@ -2670,6 +2681,7 @@
           <a:lstStyle xmlns:a="http://schemas.openxmlformats.org/drawingml/2006/main"/>
           <a:p xmlns:a="http://schemas.openxmlformats.org/drawingml/2006/main">
             <a:pPr algn="l">
+              <a:buNone/>
               <a:defRPr sz="1350" b="0">
                 <a:solidFill>
                   <a:srgbClr val="536273"/>
@@ -2693,6 +2705,7 @@
           </a:p>
           <a:p xmlns:a="http://schemas.openxmlformats.org/drawingml/2006/main">
             <a:pPr algn="l">
+              <a:buNone/>
               <a:defRPr sz="1350" b="0">
                 <a:solidFill>
                   <a:srgbClr val="536273"/>
@@ -2817,6 +2830,7 @@
           <a:lstStyle xmlns:a="http://schemas.openxmlformats.org/drawingml/2006/main"/>
           <a:p xmlns:a="http://schemas.openxmlformats.org/drawingml/2006/main">
             <a:pPr algn="l">
+              <a:buNone/>
               <a:defRPr sz="1800" b="1">
                 <a:solidFill>
                   <a:srgbClr val="0B1B2B"/>
@@ -2875,6 +2889,7 @@
           <a:lstStyle xmlns:a="http://schemas.openxmlformats.org/drawingml/2006/main"/>
           <a:p xmlns:a="http://schemas.openxmlformats.org/drawingml/2006/main">
             <a:pPr algn="l">
+              <a:buNone/>
               <a:defRPr sz="1350" b="0">
                 <a:solidFill>
                   <a:srgbClr val="536273"/>
@@ -2898,6 +2913,7 @@
           </a:p>
           <a:p xmlns:a="http://schemas.openxmlformats.org/drawingml/2006/main">
             <a:pPr algn="l">
+              <a:buNone/>
               <a:defRPr sz="1350" b="0">
                 <a:solidFill>
                   <a:srgbClr val="536273"/>
@@ -3022,6 +3038,7 @@
           <a:lstStyle xmlns:a="http://schemas.openxmlformats.org/drawingml/2006/main"/>
           <a:p xmlns:a="http://schemas.openxmlformats.org/drawingml/2006/main">
             <a:pPr algn="l">
+              <a:buNone/>
               <a:defRPr sz="1800" b="1">
                 <a:solidFill>
                   <a:srgbClr val="0B1B2B"/>
@@ -3080,6 +3097,7 @@
           <a:lstStyle xmlns:a="http://schemas.openxmlformats.org/drawingml/2006/main"/>
           <a:p xmlns:a="http://schemas.openxmlformats.org/drawingml/2006/main">
             <a:pPr algn="l">
+              <a:buNone/>
               <a:defRPr sz="1350" b="0">
                 <a:solidFill>
                   <a:srgbClr val="536273"/>
@@ -3103,6 +3121,7 @@
           </a:p>
           <a:p xmlns:a="http://schemas.openxmlformats.org/drawingml/2006/main">
             <a:pPr algn="l">
+              <a:buNone/>
               <a:defRPr sz="1350" b="0">
                 <a:solidFill>
                   <a:srgbClr val="536273"/>
@@ -3161,6 +3180,7 @@
           <a:lstStyle xmlns:a="http://schemas.openxmlformats.org/drawingml/2006/main"/>
           <a:p xmlns:a="http://schemas.openxmlformats.org/drawingml/2006/main">
             <a:pPr algn="ctr">
+              <a:buNone/>
               <a:defRPr sz="1500" b="0">
                 <a:solidFill>
                   <a:srgbClr val="536273"/>
@@ -3179,7 +3199,7 @@
                 <a:ea typeface="Arial"/>
                 <a:cs typeface="Arial"/>
               </a:rPr>
-              <a:t>La configuración sensible se mantiene únicamente en Render. El backend Starter permite el envío SMTP de credenciales iniciales.</a:t>
+              <a:t>La configuración sensible se mantiene únicamente en Render. El backend Starter permite el envío de credenciales mediante Gmail SMTP.</a:t>
             </a:r>
           </a:p>
         </p:txBody>
@@ -3241,6 +3261,7 @@
           <a:lstStyle xmlns:a="http://schemas.openxmlformats.org/drawingml/2006/main"/>
           <a:p xmlns:a="http://schemas.openxmlformats.org/drawingml/2006/main">
             <a:pPr algn="l">
+              <a:buNone/>
               <a:defRPr sz="1050" b="1">
                 <a:solidFill>
                   <a:srgbClr val="3D8DFF"/>
@@ -3299,6 +3320,7 @@
           <a:lstStyle xmlns:a="http://schemas.openxmlformats.org/drawingml/2006/main"/>
           <a:p xmlns:a="http://schemas.openxmlformats.org/drawingml/2006/main">
             <a:pPr algn="l">
+              <a:buNone/>
               <a:defRPr sz="2850" b="1">
                 <a:solidFill>
                   <a:srgbClr val="0B1B2B"/>
@@ -3419,6 +3441,7 @@
           <a:lstStyle xmlns:a="http://schemas.openxmlformats.org/drawingml/2006/main"/>
           <a:p xmlns:a="http://schemas.openxmlformats.org/drawingml/2006/main">
             <a:pPr algn="l">
+              <a:buNone/>
               <a:defRPr sz="975" b="0">
                 <a:solidFill>
                   <a:srgbClr val="536273"/>
@@ -3477,6 +3500,7 @@
           <a:lstStyle xmlns:a="http://schemas.openxmlformats.org/drawingml/2006/main"/>
           <a:p xmlns:a="http://schemas.openxmlformats.org/drawingml/2006/main">
             <a:pPr algn="r">
+              <a:buNone/>
               <a:defRPr sz="975" b="0">
                 <a:solidFill>
                   <a:srgbClr val="536273"/>
@@ -3601,6 +3625,7 @@
           <a:lstStyle xmlns:a="http://schemas.openxmlformats.org/drawingml/2006/main"/>
           <a:p xmlns:a="http://schemas.openxmlformats.org/drawingml/2006/main">
             <a:pPr algn="l">
+              <a:buNone/>
               <a:defRPr sz="1800" b="1">
                 <a:solidFill>
                   <a:srgbClr val="0B1B2B"/>
@@ -3659,6 +3684,7 @@
           <a:lstStyle xmlns:a="http://schemas.openxmlformats.org/drawingml/2006/main"/>
           <a:p xmlns:a="http://schemas.openxmlformats.org/drawingml/2006/main">
             <a:pPr algn="l">
+              <a:buNone/>
               <a:defRPr sz="1350" b="0">
                 <a:solidFill>
                   <a:srgbClr val="536273"/>
@@ -3677,7 +3703,7 @@
                 <a:ea typeface="Arial"/>
                 <a:cs typeface="Arial"/>
               </a:rPr>
-              <a:t>Registro y login · cambio obligatorio de contraseña · planificación · geocodificación · ruta circular · mapa · GPX · meteorología · análisis de viento · fallback por distancia · despliegue.</a:t>
+              <a:t>Registro y login · cambio obligatorio de contraseña · planificación · geocodificación · rutas circulares e ida y vuelta · mapa · flechas de viento por riesgo · GPX · meteorología · análisis de viento · fallback por distancia · despliegue.</a:t>
             </a:r>
           </a:p>
         </p:txBody>
@@ -3783,6 +3809,7 @@
           <a:lstStyle xmlns:a="http://schemas.openxmlformats.org/drawingml/2006/main"/>
           <a:p xmlns:a="http://schemas.openxmlformats.org/drawingml/2006/main">
             <a:pPr algn="l">
+              <a:buNone/>
               <a:defRPr sz="1800" b="1">
                 <a:solidFill>
                   <a:srgbClr val="0B1B2B"/>
@@ -3841,6 +3868,7 @@
           <a:lstStyle xmlns:a="http://schemas.openxmlformats.org/drawingml/2006/main"/>
           <a:p xmlns:a="http://schemas.openxmlformats.org/drawingml/2006/main">
             <a:pPr algn="l">
+              <a:buNone/>
               <a:defRPr sz="1350" b="0">
                 <a:solidFill>
                   <a:srgbClr val="536273"/>
@@ -3899,6 +3927,7 @@
           <a:lstStyle xmlns:a="http://schemas.openxmlformats.org/drawingml/2006/main"/>
           <a:p xmlns:a="http://schemas.openxmlformats.org/drawingml/2006/main">
             <a:pPr algn="ctr">
+              <a:buNone/>
               <a:defRPr sz="1500" b="1">
                 <a:solidFill>
                   <a:srgbClr val="0B1B2B"/>
@@ -3979,6 +4008,7 @@
           <a:lstStyle xmlns:a="http://schemas.openxmlformats.org/drawingml/2006/main"/>
           <a:p xmlns:a="http://schemas.openxmlformats.org/drawingml/2006/main">
             <a:pPr algn="l">
+              <a:buNone/>
               <a:defRPr sz="1125" b="1">
                 <a:solidFill>
                   <a:srgbClr val="3D8DFF"/>
@@ -4037,6 +4067,7 @@
           <a:lstStyle xmlns:a="http://schemas.openxmlformats.org/drawingml/2006/main"/>
           <a:p xmlns:a="http://schemas.openxmlformats.org/drawingml/2006/main">
             <a:pPr algn="l">
+              <a:buNone/>
               <a:defRPr sz="3900" b="1">
                 <a:solidFill>
                   <a:srgbClr val="0B1B2B"/>
@@ -4055,7 +4086,7 @@
                 <a:ea typeface="Arial"/>
                 <a:cs typeface="Arial"/>
               </a:rPr>
-              <a:t>CicloViento convierte datos de ruta y viento en una decisión más informada.</a:t>
+              <a:t>CicloViento convierte datos de ruta, meteorología y viento en una decisión más informada.</a:t>
             </a:r>
           </a:p>
         </p:txBody>
@@ -4095,6 +4126,7 @@
           <a:lstStyle xmlns:a="http://schemas.openxmlformats.org/drawingml/2006/main"/>
           <a:p xmlns:a="http://schemas.openxmlformats.org/drawingml/2006/main">
             <a:pPr algn="l">
+              <a:buNone/>
               <a:defRPr sz="1800" b="0">
                 <a:solidFill>
                   <a:srgbClr val="536273"/>
@@ -4113,7 +4145,7 @@
                 <a:ea typeface="Arial"/>
                 <a:cs typeface="Arial"/>
               </a:rPr>
-              <a:t>Una base funcional y desplegada que conserva la separación arquitectónica necesaria para evolucionar el sistema.</a:t>
+              <a:t>Una base funcional y desplegada que conserva rutas reales, comunica sus límites y mantiene una arquitectura preparada para evolucionar.</a:t>
             </a:r>
           </a:p>
         </p:txBody>
@@ -4188,6 +4220,7 @@
           <a:lstStyle xmlns:a="http://schemas.openxmlformats.org/drawingml/2006/main"/>
           <a:p xmlns:a="http://schemas.openxmlformats.org/drawingml/2006/main">
             <a:pPr algn="ctr">
+              <a:buNone/>
               <a:defRPr sz="1650" b="1">
                 <a:solidFill>
                   <a:srgbClr val="0B1B2B"/>
@@ -4246,6 +4279,7 @@
           <a:lstStyle xmlns:a="http://schemas.openxmlformats.org/drawingml/2006/main"/>
           <a:p xmlns:a="http://schemas.openxmlformats.org/drawingml/2006/main">
             <a:pPr algn="ctr">
+              <a:buNone/>
               <a:defRPr sz="1500" b="1">
                 <a:solidFill>
                   <a:srgbClr val="3D8DFF"/>
@@ -4335,6 +4369,7 @@
           <a:lstStyle xmlns:a="http://schemas.openxmlformats.org/drawingml/2006/main"/>
           <a:p xmlns:a="http://schemas.openxmlformats.org/drawingml/2006/main">
             <a:pPr algn="l">
+              <a:buNone/>
               <a:defRPr sz="975" b="0">
                 <a:solidFill>
                   <a:srgbClr val="536273"/>
@@ -4393,6 +4428,7 @@
           <a:lstStyle xmlns:a="http://schemas.openxmlformats.org/drawingml/2006/main"/>
           <a:p xmlns:a="http://schemas.openxmlformats.org/drawingml/2006/main">
             <a:pPr algn="r">
+              <a:buNone/>
               <a:defRPr sz="975" b="0">
                 <a:solidFill>
                   <a:srgbClr val="536273"/>
@@ -4473,6 +4509,7 @@
           <a:lstStyle xmlns:a="http://schemas.openxmlformats.org/drawingml/2006/main"/>
           <a:p xmlns:a="http://schemas.openxmlformats.org/drawingml/2006/main">
             <a:pPr algn="l">
+              <a:buNone/>
               <a:defRPr sz="1050" b="1">
                 <a:solidFill>
                   <a:srgbClr val="3D8DFF"/>
@@ -4531,6 +4568,7 @@
           <a:lstStyle xmlns:a="http://schemas.openxmlformats.org/drawingml/2006/main"/>
           <a:p xmlns:a="http://schemas.openxmlformats.org/drawingml/2006/main">
             <a:pPr algn="l">
+              <a:buNone/>
               <a:defRPr sz="2850" b="1">
                 <a:solidFill>
                   <a:srgbClr val="0B1B2B"/>
@@ -4651,6 +4689,7 @@
           <a:lstStyle xmlns:a="http://schemas.openxmlformats.org/drawingml/2006/main"/>
           <a:p xmlns:a="http://schemas.openxmlformats.org/drawingml/2006/main">
             <a:pPr algn="l">
+              <a:buNone/>
               <a:defRPr sz="975" b="0">
                 <a:solidFill>
                   <a:srgbClr val="536273"/>
@@ -4709,6 +4748,7 @@
           <a:lstStyle xmlns:a="http://schemas.openxmlformats.org/drawingml/2006/main"/>
           <a:p xmlns:a="http://schemas.openxmlformats.org/drawingml/2006/main">
             <a:pPr algn="r">
+              <a:buNone/>
               <a:defRPr sz="975" b="0">
                 <a:solidFill>
                   <a:srgbClr val="536273"/>
@@ -4833,6 +4873,7 @@
           <a:lstStyle xmlns:a="http://schemas.openxmlformats.org/drawingml/2006/main"/>
           <a:p xmlns:a="http://schemas.openxmlformats.org/drawingml/2006/main">
             <a:pPr algn="l">
+              <a:buNone/>
               <a:defRPr sz="1800" b="1">
                 <a:solidFill>
                   <a:srgbClr val="0B1B2B"/>
@@ -4891,6 +4932,7 @@
           <a:lstStyle xmlns:a="http://schemas.openxmlformats.org/drawingml/2006/main"/>
           <a:p xmlns:a="http://schemas.openxmlformats.org/drawingml/2006/main">
             <a:pPr algn="l">
+              <a:buNone/>
               <a:defRPr sz="1350" b="0">
                 <a:solidFill>
                   <a:srgbClr val="536273"/>
@@ -5015,6 +5057,7 @@
           <a:lstStyle xmlns:a="http://schemas.openxmlformats.org/drawingml/2006/main"/>
           <a:p xmlns:a="http://schemas.openxmlformats.org/drawingml/2006/main">
             <a:pPr algn="l">
+              <a:buNone/>
               <a:defRPr sz="1800" b="1">
                 <a:solidFill>
                   <a:srgbClr val="0B1B2B"/>
@@ -5073,6 +5116,7 @@
           <a:lstStyle xmlns:a="http://schemas.openxmlformats.org/drawingml/2006/main"/>
           <a:p xmlns:a="http://schemas.openxmlformats.org/drawingml/2006/main">
             <a:pPr algn="l">
+              <a:buNone/>
               <a:defRPr sz="1350" b="0">
                 <a:solidFill>
                   <a:srgbClr val="536273"/>
@@ -5197,6 +5241,7 @@
           <a:lstStyle xmlns:a="http://schemas.openxmlformats.org/drawingml/2006/main"/>
           <a:p xmlns:a="http://schemas.openxmlformats.org/drawingml/2006/main">
             <a:pPr algn="l">
+              <a:buNone/>
               <a:defRPr sz="1800" b="1">
                 <a:solidFill>
                   <a:srgbClr val="0B1B2B"/>
@@ -5255,6 +5300,7 @@
           <a:lstStyle xmlns:a="http://schemas.openxmlformats.org/drawingml/2006/main"/>
           <a:p xmlns:a="http://schemas.openxmlformats.org/drawingml/2006/main">
             <a:pPr algn="l">
+              <a:buNone/>
               <a:defRPr sz="1350" b="0">
                 <a:solidFill>
                   <a:srgbClr val="536273"/>
@@ -5313,6 +5359,7 @@
           <a:lstStyle xmlns:a="http://schemas.openxmlformats.org/drawingml/2006/main"/>
           <a:p xmlns:a="http://schemas.openxmlformats.org/drawingml/2006/main">
             <a:pPr algn="l">
+              <a:buNone/>
               <a:defRPr sz="1500" b="1">
                 <a:solidFill>
                   <a:srgbClr val="0B1B2B"/>
@@ -5393,6 +5440,7 @@
           <a:lstStyle xmlns:a="http://schemas.openxmlformats.org/drawingml/2006/main"/>
           <a:p xmlns:a="http://schemas.openxmlformats.org/drawingml/2006/main">
             <a:pPr algn="l">
+              <a:buNone/>
               <a:defRPr sz="1050" b="1">
                 <a:solidFill>
                   <a:srgbClr val="3D8DFF"/>
@@ -5451,6 +5499,7 @@
           <a:lstStyle xmlns:a="http://schemas.openxmlformats.org/drawingml/2006/main"/>
           <a:p xmlns:a="http://schemas.openxmlformats.org/drawingml/2006/main">
             <a:pPr algn="l">
+              <a:buNone/>
               <a:defRPr sz="2850" b="1">
                 <a:solidFill>
                   <a:srgbClr val="0B1B2B"/>
@@ -5571,6 +5620,7 @@
           <a:lstStyle xmlns:a="http://schemas.openxmlformats.org/drawingml/2006/main"/>
           <a:p xmlns:a="http://schemas.openxmlformats.org/drawingml/2006/main">
             <a:pPr algn="l">
+              <a:buNone/>
               <a:defRPr sz="975" b="0">
                 <a:solidFill>
                   <a:srgbClr val="536273"/>
@@ -5629,6 +5679,7 @@
           <a:lstStyle xmlns:a="http://schemas.openxmlformats.org/drawingml/2006/main"/>
           <a:p xmlns:a="http://schemas.openxmlformats.org/drawingml/2006/main">
             <a:pPr algn="r">
+              <a:buNone/>
               <a:defRPr sz="975" b="0">
                 <a:solidFill>
                   <a:srgbClr val="536273"/>
@@ -5846,6 +5897,7 @@
           <a:lstStyle xmlns:a="http://schemas.openxmlformats.org/drawingml/2006/main"/>
           <a:p xmlns:a="http://schemas.openxmlformats.org/drawingml/2006/main">
             <a:pPr algn="ctr">
+              <a:buNone/>
               <a:defRPr sz="1425" b="1">
                 <a:solidFill>
                   <a:srgbClr val="0B1B2B"/>
@@ -5904,6 +5956,7 @@
           <a:lstStyle xmlns:a="http://schemas.openxmlformats.org/drawingml/2006/main"/>
           <a:p xmlns:a="http://schemas.openxmlformats.org/drawingml/2006/main">
             <a:pPr algn="ctr">
+              <a:buNone/>
               <a:defRPr sz="1125" b="0">
                 <a:solidFill>
                   <a:srgbClr val="536273"/>
@@ -5997,6 +6050,7 @@
           <a:lstStyle xmlns:a="http://schemas.openxmlformats.org/drawingml/2006/main"/>
           <a:p xmlns:a="http://schemas.openxmlformats.org/drawingml/2006/main">
             <a:pPr algn="ctr">
+              <a:buNone/>
               <a:defRPr sz="1425" b="1">
                 <a:solidFill>
                   <a:srgbClr val="0B1B2B"/>
@@ -6055,6 +6109,7 @@
           <a:lstStyle xmlns:a="http://schemas.openxmlformats.org/drawingml/2006/main"/>
           <a:p xmlns:a="http://schemas.openxmlformats.org/drawingml/2006/main">
             <a:pPr algn="ctr">
+              <a:buNone/>
               <a:defRPr sz="1125" b="0">
                 <a:solidFill>
                   <a:srgbClr val="536273"/>
@@ -6148,6 +6203,7 @@
           <a:lstStyle xmlns:a="http://schemas.openxmlformats.org/drawingml/2006/main"/>
           <a:p xmlns:a="http://schemas.openxmlformats.org/drawingml/2006/main">
             <a:pPr algn="ctr">
+              <a:buNone/>
               <a:defRPr sz="1425" b="1">
                 <a:solidFill>
                   <a:srgbClr val="0B1B2B"/>
@@ -6206,6 +6262,7 @@
           <a:lstStyle xmlns:a="http://schemas.openxmlformats.org/drawingml/2006/main"/>
           <a:p xmlns:a="http://schemas.openxmlformats.org/drawingml/2006/main">
             <a:pPr algn="ctr">
+              <a:buNone/>
               <a:defRPr sz="1125" b="0">
                 <a:solidFill>
                   <a:srgbClr val="536273"/>
@@ -6299,6 +6356,7 @@
           <a:lstStyle xmlns:a="http://schemas.openxmlformats.org/drawingml/2006/main"/>
           <a:p xmlns:a="http://schemas.openxmlformats.org/drawingml/2006/main">
             <a:pPr algn="ctr">
+              <a:buNone/>
               <a:defRPr sz="1425" b="1">
                 <a:solidFill>
                   <a:srgbClr val="0B1B2B"/>
@@ -6357,6 +6415,7 @@
           <a:lstStyle xmlns:a="http://schemas.openxmlformats.org/drawingml/2006/main"/>
           <a:p xmlns:a="http://schemas.openxmlformats.org/drawingml/2006/main">
             <a:pPr algn="ctr">
+              <a:buNone/>
               <a:defRPr sz="1125" b="0">
                 <a:solidFill>
                   <a:srgbClr val="536273"/>
@@ -6450,6 +6509,7 @@
           <a:lstStyle xmlns:a="http://schemas.openxmlformats.org/drawingml/2006/main"/>
           <a:p xmlns:a="http://schemas.openxmlformats.org/drawingml/2006/main">
             <a:pPr algn="ctr">
+              <a:buNone/>
               <a:defRPr sz="1425" b="1">
                 <a:solidFill>
                   <a:srgbClr val="0B1B2B"/>
@@ -6508,6 +6568,7 @@
           <a:lstStyle xmlns:a="http://schemas.openxmlformats.org/drawingml/2006/main"/>
           <a:p xmlns:a="http://schemas.openxmlformats.org/drawingml/2006/main">
             <a:pPr algn="ctr">
+              <a:buNone/>
               <a:defRPr sz="1125" b="0">
                 <a:solidFill>
                   <a:srgbClr val="536273"/>
@@ -6526,7 +6587,7 @@
                 <a:ea typeface="Arial"/>
                 <a:cs typeface="Arial"/>
               </a:rPr>
-              <a:t>Consulta y análisis por segmentos</a:t>
+              <a:t>Consulta, análisis y flechas de color por nivel de riesgo</a:t>
             </a:r>
           </a:p>
         </p:txBody>
@@ -6566,6 +6627,7 @@
           <a:lstStyle xmlns:a="http://schemas.openxmlformats.org/drawingml/2006/main"/>
           <a:p xmlns:a="http://schemas.openxmlformats.org/drawingml/2006/main">
             <a:pPr algn="ctr">
+              <a:buNone/>
               <a:defRPr sz="1650" b="0">
                 <a:solidFill>
                   <a:srgbClr val="536273"/>
@@ -6646,6 +6708,7 @@
           <a:lstStyle xmlns:a="http://schemas.openxmlformats.org/drawingml/2006/main"/>
           <a:p xmlns:a="http://schemas.openxmlformats.org/drawingml/2006/main">
             <a:pPr algn="l">
+              <a:buNone/>
               <a:defRPr sz="1050" b="1">
                 <a:solidFill>
                   <a:srgbClr val="3D8DFF"/>
@@ -6704,6 +6767,7 @@
           <a:lstStyle xmlns:a="http://schemas.openxmlformats.org/drawingml/2006/main"/>
           <a:p xmlns:a="http://schemas.openxmlformats.org/drawingml/2006/main">
             <a:pPr algn="l">
+              <a:buNone/>
               <a:defRPr sz="2850" b="1">
                 <a:solidFill>
                   <a:srgbClr val="0B1B2B"/>
@@ -6722,7 +6786,7 @@
                 <a:ea typeface="Arial"/>
                 <a:cs typeface="Arial"/>
               </a:rPr>
-              <a:t>Una petición se transforma en un recorrido circular real</a:t>
+              <a:t>Una petición produce una ruta real: circular o de ida y vuelta</a:t>
             </a:r>
           </a:p>
         </p:txBody>
@@ -6824,6 +6888,7 @@
           <a:lstStyle xmlns:a="http://schemas.openxmlformats.org/drawingml/2006/main"/>
           <a:p xmlns:a="http://schemas.openxmlformats.org/drawingml/2006/main">
             <a:pPr algn="l">
+              <a:buNone/>
               <a:defRPr sz="975" b="0">
                 <a:solidFill>
                   <a:srgbClr val="536273"/>
@@ -6882,6 +6947,7 @@
           <a:lstStyle xmlns:a="http://schemas.openxmlformats.org/drawingml/2006/main"/>
           <a:p xmlns:a="http://schemas.openxmlformats.org/drawingml/2006/main">
             <a:pPr algn="r">
+              <a:buNone/>
               <a:defRPr sz="975" b="0">
                 <a:solidFill>
                   <a:srgbClr val="536273"/>
@@ -7068,6 +7134,7 @@
           <a:lstStyle xmlns:a="http://schemas.openxmlformats.org/drawingml/2006/main"/>
           <a:p xmlns:a="http://schemas.openxmlformats.org/drawingml/2006/main">
             <a:pPr algn="ctr">
+              <a:buNone/>
               <a:defRPr sz="1425" b="1">
                 <a:solidFill>
                   <a:srgbClr val="0B1B2B"/>
@@ -7126,6 +7193,7 @@
           <a:lstStyle xmlns:a="http://schemas.openxmlformats.org/drawingml/2006/main"/>
           <a:p xmlns:a="http://schemas.openxmlformats.org/drawingml/2006/main">
             <a:pPr algn="ctr">
+              <a:buNone/>
               <a:defRPr sz="1125" b="0">
                 <a:solidFill>
                   <a:srgbClr val="536273"/>
@@ -7219,6 +7287,7 @@
           <a:lstStyle xmlns:a="http://schemas.openxmlformats.org/drawingml/2006/main"/>
           <a:p xmlns:a="http://schemas.openxmlformats.org/drawingml/2006/main">
             <a:pPr algn="ctr">
+              <a:buNone/>
               <a:defRPr sz="1425" b="1">
                 <a:solidFill>
                   <a:srgbClr val="0B1B2B"/>
@@ -7277,6 +7346,7 @@
           <a:lstStyle xmlns:a="http://schemas.openxmlformats.org/drawingml/2006/main"/>
           <a:p xmlns:a="http://schemas.openxmlformats.org/drawingml/2006/main">
             <a:pPr algn="ctr">
+              <a:buNone/>
               <a:defRPr sz="1125" b="0">
                 <a:solidFill>
                   <a:srgbClr val="536273"/>
@@ -7370,6 +7440,7 @@
           <a:lstStyle xmlns:a="http://schemas.openxmlformats.org/drawingml/2006/main"/>
           <a:p xmlns:a="http://schemas.openxmlformats.org/drawingml/2006/main">
             <a:pPr algn="ctr">
+              <a:buNone/>
               <a:defRPr sz="1425" b="1">
                 <a:solidFill>
                   <a:srgbClr val="0B1B2B"/>
@@ -7428,6 +7499,7 @@
           <a:lstStyle xmlns:a="http://schemas.openxmlformats.org/drawingml/2006/main"/>
           <a:p xmlns:a="http://schemas.openxmlformats.org/drawingml/2006/main">
             <a:pPr algn="ctr">
+              <a:buNone/>
               <a:defRPr sz="1125" b="0">
                 <a:solidFill>
                   <a:srgbClr val="536273"/>
@@ -7446,7 +7518,7 @@
                 <a:ea typeface="Arial"/>
                 <a:cs typeface="Arial"/>
               </a:rPr>
-              <a:t>cycling-road · round-trip</a:t>
+              <a:t>cycling-road · circuito o ida y vuelta real</a:t>
             </a:r>
           </a:p>
         </p:txBody>
@@ -7521,6 +7593,7 @@
           <a:lstStyle xmlns:a="http://schemas.openxmlformats.org/drawingml/2006/main"/>
           <a:p xmlns:a="http://schemas.openxmlformats.org/drawingml/2006/main">
             <a:pPr algn="ctr">
+              <a:buNone/>
               <a:defRPr sz="1425" b="1">
                 <a:solidFill>
                   <a:srgbClr val="0B1B2B"/>
@@ -7579,6 +7652,7 @@
           <a:lstStyle xmlns:a="http://schemas.openxmlformats.org/drawingml/2006/main"/>
           <a:p xmlns:a="http://schemas.openxmlformats.org/drawingml/2006/main">
             <a:pPr algn="ctr">
+              <a:buNone/>
               <a:defRPr sz="1125" b="0">
                 <a:solidFill>
                   <a:srgbClr val="536273"/>
@@ -7637,6 +7711,7 @@
           <a:lstStyle xmlns:a="http://schemas.openxmlformats.org/drawingml/2006/main"/>
           <a:p xmlns:a="http://schemas.openxmlformats.org/drawingml/2006/main">
             <a:pPr algn="ctr">
+              <a:buNone/>
               <a:defRPr sz="1650" b="0">
                 <a:solidFill>
                   <a:srgbClr val="536273"/>
@@ -7655,7 +7730,7 @@
                 <a:ea typeface="Arial"/>
                 <a:cs typeface="Arial"/>
               </a:rPr>
-              <a:t>La aplicación diferencia distancia solicitada y distancia generada; no inventa geometrías cuando el proveedor no devuelve una ruta real.</a:t>
+              <a:t>Si ORS no encuentra un circuito, se calcula una ida y un regreso reales por separado. La aplicación no invierte geometrías ni inventa recorridos.</a:t>
             </a:r>
           </a:p>
         </p:txBody>
@@ -7717,6 +7792,7 @@
           <a:lstStyle xmlns:a="http://schemas.openxmlformats.org/drawingml/2006/main"/>
           <a:p xmlns:a="http://schemas.openxmlformats.org/drawingml/2006/main">
             <a:pPr algn="l">
+              <a:buNone/>
               <a:defRPr sz="1050" b="1">
                 <a:solidFill>
                   <a:srgbClr val="3D8DFF"/>
@@ -7775,6 +7851,7 @@
           <a:lstStyle xmlns:a="http://schemas.openxmlformats.org/drawingml/2006/main"/>
           <a:p xmlns:a="http://schemas.openxmlformats.org/drawingml/2006/main">
             <a:pPr algn="l">
+              <a:buNone/>
               <a:defRPr sz="2850" b="1">
                 <a:solidFill>
                   <a:srgbClr val="0B1B2B"/>
@@ -7895,6 +7972,7 @@
           <a:lstStyle xmlns:a="http://schemas.openxmlformats.org/drawingml/2006/main"/>
           <a:p xmlns:a="http://schemas.openxmlformats.org/drawingml/2006/main">
             <a:pPr algn="l">
+              <a:buNone/>
               <a:defRPr sz="975" b="0">
                 <a:solidFill>
                   <a:srgbClr val="536273"/>
@@ -7953,6 +8031,7 @@
           <a:lstStyle xmlns:a="http://schemas.openxmlformats.org/drawingml/2006/main"/>
           <a:p xmlns:a="http://schemas.openxmlformats.org/drawingml/2006/main">
             <a:pPr algn="r">
+              <a:buNone/>
               <a:defRPr sz="975" b="0">
                 <a:solidFill>
                   <a:srgbClr val="536273"/>
@@ -8077,6 +8156,7 @@
           <a:lstStyle xmlns:a="http://schemas.openxmlformats.org/drawingml/2006/main"/>
           <a:p xmlns:a="http://schemas.openxmlformats.org/drawingml/2006/main">
             <a:pPr algn="l">
+              <a:buNone/>
               <a:defRPr sz="1800" b="1">
                 <a:solidFill>
                   <a:srgbClr val="0B1B2B"/>
@@ -8135,6 +8215,7 @@
           <a:lstStyle xmlns:a="http://schemas.openxmlformats.org/drawingml/2006/main"/>
           <a:p xmlns:a="http://schemas.openxmlformats.org/drawingml/2006/main">
             <a:pPr algn="l">
+              <a:buNone/>
               <a:defRPr sz="1350" b="0">
                 <a:solidFill>
                   <a:srgbClr val="536273"/>
@@ -8259,6 +8340,7 @@
           <a:lstStyle xmlns:a="http://schemas.openxmlformats.org/drawingml/2006/main"/>
           <a:p xmlns:a="http://schemas.openxmlformats.org/drawingml/2006/main">
             <a:pPr algn="l">
+              <a:buNone/>
               <a:defRPr sz="1800" b="1">
                 <a:solidFill>
                   <a:srgbClr val="0B1B2B"/>
@@ -8317,6 +8399,7 @@
           <a:lstStyle xmlns:a="http://schemas.openxmlformats.org/drawingml/2006/main"/>
           <a:p xmlns:a="http://schemas.openxmlformats.org/drawingml/2006/main">
             <a:pPr algn="l">
+              <a:buNone/>
               <a:defRPr sz="1350" b="0">
                 <a:solidFill>
                   <a:srgbClr val="536273"/>
@@ -8441,6 +8524,7 @@
           <a:lstStyle xmlns:a="http://schemas.openxmlformats.org/drawingml/2006/main"/>
           <a:p xmlns:a="http://schemas.openxmlformats.org/drawingml/2006/main">
             <a:pPr algn="l">
+              <a:buNone/>
               <a:defRPr sz="1800" b="1">
                 <a:solidFill>
                   <a:srgbClr val="0B1B2B"/>
@@ -8499,6 +8583,7 @@
           <a:lstStyle xmlns:a="http://schemas.openxmlformats.org/drawingml/2006/main"/>
           <a:p xmlns:a="http://schemas.openxmlformats.org/drawingml/2006/main">
             <a:pPr algn="l">
+              <a:buNone/>
               <a:defRPr sz="1350" b="0">
                 <a:solidFill>
                   <a:srgbClr val="536273"/>
@@ -8557,6 +8642,7 @@
           <a:lstStyle xmlns:a="http://schemas.openxmlformats.org/drawingml/2006/main"/>
           <a:p xmlns:a="http://schemas.openxmlformats.org/drawingml/2006/main">
             <a:pPr algn="ctr">
+              <a:buNone/>
               <a:defRPr sz="1500" b="0">
                 <a:solidFill>
                   <a:srgbClr val="536273"/>
@@ -8637,6 +8723,7 @@
           <a:lstStyle xmlns:a="http://schemas.openxmlformats.org/drawingml/2006/main"/>
           <a:p xmlns:a="http://schemas.openxmlformats.org/drawingml/2006/main">
             <a:pPr algn="l">
+              <a:buNone/>
               <a:defRPr sz="1050" b="1">
                 <a:solidFill>
                   <a:srgbClr val="3D8DFF"/>
@@ -8695,6 +8782,7 @@
           <a:lstStyle xmlns:a="http://schemas.openxmlformats.org/drawingml/2006/main"/>
           <a:p xmlns:a="http://schemas.openxmlformats.org/drawingml/2006/main">
             <a:pPr algn="l">
+              <a:buNone/>
               <a:defRPr sz="2850" b="1">
                 <a:solidFill>
                   <a:srgbClr val="0B1B2B"/>
@@ -8713,7 +8801,7 @@
                 <a:ea typeface="Arial"/>
                 <a:cs typeface="Arial"/>
               </a:rPr>
-              <a:t>El resultado se calcula sobre la geometría de la ruta</a:t>
+              <a:t>El análisis y el mapa explican el viento sobre la ruta real</a:t>
             </a:r>
           </a:p>
         </p:txBody>
@@ -8815,6 +8903,7 @@
           <a:lstStyle xmlns:a="http://schemas.openxmlformats.org/drawingml/2006/main"/>
           <a:p xmlns:a="http://schemas.openxmlformats.org/drawingml/2006/main">
             <a:pPr algn="l">
+              <a:buNone/>
               <a:defRPr sz="975" b="0">
                 <a:solidFill>
                   <a:srgbClr val="536273"/>
@@ -8873,6 +8962,7 @@
           <a:lstStyle xmlns:a="http://schemas.openxmlformats.org/drawingml/2006/main"/>
           <a:p xmlns:a="http://schemas.openxmlformats.org/drawingml/2006/main">
             <a:pPr algn="r">
+              <a:buNone/>
               <a:defRPr sz="975" b="0">
                 <a:solidFill>
                   <a:srgbClr val="536273"/>
@@ -8997,6 +9087,7 @@
           <a:lstStyle xmlns:a="http://schemas.openxmlformats.org/drawingml/2006/main"/>
           <a:p xmlns:a="http://schemas.openxmlformats.org/drawingml/2006/main">
             <a:pPr algn="l">
+              <a:buNone/>
               <a:defRPr sz="1800" b="1">
                 <a:solidFill>
                   <a:srgbClr val="0B1B2B"/>
@@ -9015,7 +9106,7 @@
                 <a:ea typeface="Arial"/>
                 <a:cs typeface="Arial"/>
               </a:rPr>
-              <a:t>1. Segmentación</a:t>
+              <a:t>1. Ruta real</a:t>
             </a:r>
           </a:p>
         </p:txBody>
@@ -9055,6 +9146,7 @@
           <a:lstStyle xmlns:a="http://schemas.openxmlformats.org/drawingml/2006/main"/>
           <a:p xmlns:a="http://schemas.openxmlformats.org/drawingml/2006/main">
             <a:pPr algn="l">
+              <a:buNone/>
               <a:defRPr sz="1350" b="0">
                 <a:solidFill>
                   <a:srgbClr val="536273"/>
@@ -9073,7 +9165,7 @@
                 <a:ea typeface="Arial"/>
                 <a:cs typeface="Arial"/>
               </a:rPr>
-              <a:t>A partir de puntos consecutivos se calcula bearing y distancia Haversine.</a:t>
+              <a:t>El análisis usa la geometría mostrada: circuito o ida y vuelta, con puntos y distancias reales.</a:t>
             </a:r>
           </a:p>
         </p:txBody>
@@ -9179,6 +9271,7 @@
           <a:lstStyle xmlns:a="http://schemas.openxmlformats.org/drawingml/2006/main"/>
           <a:p xmlns:a="http://schemas.openxmlformats.org/drawingml/2006/main">
             <a:pPr algn="l">
+              <a:buNone/>
               <a:defRPr sz="1800" b="1">
                 <a:solidFill>
                   <a:srgbClr val="0B1B2B"/>
@@ -9197,7 +9290,7 @@
                 <a:ea typeface="Arial"/>
                 <a:cs typeface="Arial"/>
               </a:rPr>
-              <a:t>2. Componentes</a:t>
+              <a:t>2. Dirección e intensidad</a:t>
             </a:r>
           </a:p>
         </p:txBody>
@@ -9237,6 +9330,7 @@
           <a:lstStyle xmlns:a="http://schemas.openxmlformats.org/drawingml/2006/main"/>
           <a:p xmlns:a="http://schemas.openxmlformats.org/drawingml/2006/main">
             <a:pPr algn="l">
+              <a:buNone/>
               <a:defRPr sz="1350" b="0">
                 <a:solidFill>
                   <a:srgbClr val="536273"/>
@@ -9255,7 +9349,7 @@
                 <a:ea typeface="Arial"/>
                 <a:cs typeface="Arial"/>
               </a:rPr>
-              <a:t>La dirección meteorológica se convierte en desplazamiento del aire y se clasifica en tailwind, headwind o crosswind.</a:t>
+              <a:t>La dirección meteorológica se convierte en desplazamiento del aire y se clasifica en cola, frontal o lateral.</a:t>
             </a:r>
           </a:p>
         </p:txBody>
@@ -9361,6 +9455,7 @@
           <a:lstStyle xmlns:a="http://schemas.openxmlformats.org/drawingml/2006/main"/>
           <a:p xmlns:a="http://schemas.openxmlformats.org/drawingml/2006/main">
             <a:pPr algn="l">
+              <a:buNone/>
               <a:defRPr sz="1800" b="1">
                 <a:solidFill>
                   <a:srgbClr val="0B1B2B"/>
@@ -9379,7 +9474,7 @@
                 <a:ea typeface="Arial"/>
                 <a:cs typeface="Arial"/>
               </a:rPr>
-              <a:t>3. Resultado</a:t>
+              <a:t>3. Flechas en el mapa</a:t>
             </a:r>
           </a:p>
         </p:txBody>
@@ -9419,6 +9514,7 @@
           <a:lstStyle xmlns:a="http://schemas.openxmlformats.org/drawingml/2006/main"/>
           <a:p xmlns:a="http://schemas.openxmlformats.org/drawingml/2006/main">
             <a:pPr algn="l">
+              <a:buNone/>
               <a:defRPr sz="1350" b="0">
                 <a:solidFill>
                   <a:srgbClr val="536273"/>
@@ -9437,7 +9533,7 @@
                 <a:ea typeface="Arial"/>
                 <a:cs typeface="Arial"/>
               </a:rPr>
-              <a:t>Los porcentajes se ponderan por metros. El regreso se analiza de forma independiente y genera favorableWindScore.</a:t>
+              <a:t>Las flechas se anclan a la ruta. Su color comunica el riesgo: verde, ámbar, naranja o rojo.</a:t>
             </a:r>
           </a:p>
         </p:txBody>
@@ -9477,6 +9573,7 @@
           <a:lstStyle xmlns:a="http://schemas.openxmlformats.org/drawingml/2006/main"/>
           <a:p xmlns:a="http://schemas.openxmlformats.org/drawingml/2006/main">
             <a:pPr algn="ctr">
+              <a:buNone/>
               <a:defRPr sz="1500" b="1">
                 <a:solidFill>
                   <a:srgbClr val="0B1B2B"/>
@@ -9495,7 +9592,7 @@
                 <a:ea typeface="Arial"/>
                 <a:cs typeface="Arial"/>
               </a:rPr>
-              <a:t>El nivel de riesgo es independiente de la favorabilidad: una ruta con viento favorable no se presenta como segura si las rachas son peligrosas.</a:t>
+              <a:t>Las flechas informan del viento; no recomiendan el sentido de un circuito. La favorabilidad y la seguridad se muestran como conceptos independientes.</a:t>
             </a:r>
           </a:p>
         </p:txBody>
@@ -9557,6 +9654,7 @@
           <a:lstStyle xmlns:a="http://schemas.openxmlformats.org/drawingml/2006/main"/>
           <a:p xmlns:a="http://schemas.openxmlformats.org/drawingml/2006/main">
             <a:pPr algn="l">
+              <a:buNone/>
               <a:defRPr sz="1050" b="1">
                 <a:solidFill>
                   <a:srgbClr val="3D8DFF"/>
@@ -9615,6 +9713,7 @@
           <a:lstStyle xmlns:a="http://schemas.openxmlformats.org/drawingml/2006/main"/>
           <a:p xmlns:a="http://schemas.openxmlformats.org/drawingml/2006/main">
             <a:pPr algn="l">
+              <a:buNone/>
               <a:defRPr sz="2850" b="1">
                 <a:solidFill>
                   <a:srgbClr val="0B1B2B"/>
@@ -9633,7 +9732,7 @@
                 <a:ea typeface="Arial"/>
                 <a:cs typeface="Arial"/>
               </a:rPr>
-              <a:t>Tres candidatas y una selección explicable</a:t>
+              <a:t>Tres candidatas, fallback por distancia e ida y vuelta real</a:t>
             </a:r>
           </a:p>
         </p:txBody>
@@ -9735,6 +9834,7 @@
           <a:lstStyle xmlns:a="http://schemas.openxmlformats.org/drawingml/2006/main"/>
           <a:p xmlns:a="http://schemas.openxmlformats.org/drawingml/2006/main">
             <a:pPr algn="l">
+              <a:buNone/>
               <a:defRPr sz="975" b="0">
                 <a:solidFill>
                   <a:srgbClr val="536273"/>
@@ -9793,6 +9893,7 @@
           <a:lstStyle xmlns:a="http://schemas.openxmlformats.org/drawingml/2006/main"/>
           <a:p xmlns:a="http://schemas.openxmlformats.org/drawingml/2006/main">
             <a:pPr algn="r">
+              <a:buNone/>
               <a:defRPr sz="975" b="0">
                 <a:solidFill>
                   <a:srgbClr val="536273"/>
@@ -9886,6 +9987,7 @@
           <a:lstStyle xmlns:a="http://schemas.openxmlformats.org/drawingml/2006/main"/>
           <a:p xmlns:a="http://schemas.openxmlformats.org/drawingml/2006/main">
             <a:pPr algn="ctr">
+              <a:buNone/>
               <a:defRPr sz="1425" b="1">
                 <a:solidFill>
                   <a:srgbClr val="0B1B2B"/>
@@ -9944,6 +10046,7 @@
           <a:lstStyle xmlns:a="http://schemas.openxmlformats.org/drawingml/2006/main"/>
           <a:p xmlns:a="http://schemas.openxmlformats.org/drawingml/2006/main">
             <a:pPr algn="ctr">
+              <a:buNone/>
               <a:defRPr sz="1125" b="0">
                 <a:solidFill>
                   <a:srgbClr val="536273"/>
@@ -10068,6 +10171,7 @@
           <a:lstStyle xmlns:a="http://schemas.openxmlformats.org/drawingml/2006/main"/>
           <a:p xmlns:a="http://schemas.openxmlformats.org/drawingml/2006/main">
             <a:pPr algn="ctr">
+              <a:buNone/>
               <a:defRPr sz="1425" b="1">
                 <a:solidFill>
                   <a:srgbClr val="0B1B2B"/>
@@ -10126,6 +10230,7 @@
           <a:lstStyle xmlns:a="http://schemas.openxmlformats.org/drawingml/2006/main"/>
           <a:p xmlns:a="http://schemas.openxmlformats.org/drawingml/2006/main">
             <a:pPr algn="ctr">
+              <a:buNone/>
               <a:defRPr sz="1125" b="0">
                 <a:solidFill>
                   <a:srgbClr val="536273"/>
@@ -10250,6 +10355,7 @@
           <a:lstStyle xmlns:a="http://schemas.openxmlformats.org/drawingml/2006/main"/>
           <a:p xmlns:a="http://schemas.openxmlformats.org/drawingml/2006/main">
             <a:pPr algn="ctr">
+              <a:buNone/>
               <a:defRPr sz="1425" b="1">
                 <a:solidFill>
                   <a:srgbClr val="0B1B2B"/>
@@ -10308,6 +10414,7 @@
           <a:lstStyle xmlns:a="http://schemas.openxmlformats.org/drawingml/2006/main"/>
           <a:p xmlns:a="http://schemas.openxmlformats.org/drawingml/2006/main">
             <a:pPr algn="ctr">
+              <a:buNone/>
               <a:defRPr sz="1125" b="0">
                 <a:solidFill>
                   <a:srgbClr val="536273"/>
@@ -10396,11 +10503,12 @@
         </p:spPr>
         <p:txBody>
           <a:bodyPr xmlns:a="http://schemas.openxmlformats.org/drawingml/2006/main" lIns="0" tIns="0" rIns="0" bIns="0" anchor="t">
-            <a:normAutofit fontScale="100000"/>
+            <a:normAutofit fontScale="93113"/>
           </a:bodyPr>
           <a:lstStyle xmlns:a="http://schemas.openxmlformats.org/drawingml/2006/main"/>
           <a:p xmlns:a="http://schemas.openxmlformats.org/drawingml/2006/main">
             <a:pPr algn="ctr">
+              <a:buNone/>
               <a:defRPr sz="1425" b="1">
                 <a:solidFill>
                   <a:srgbClr val="0B1B2B"/>
@@ -10419,7 +10527,7 @@
                 <a:ea typeface="Arial"/>
                 <a:cs typeface="Arial"/>
               </a:rPr>
-              <a:t>Fallback</a:t>
+              <a:t>Fallback de distancia</a:t>
             </a:r>
           </a:p>
         </p:txBody>
@@ -10459,6 +10567,7 @@
           <a:lstStyle xmlns:a="http://schemas.openxmlformats.org/drawingml/2006/main"/>
           <a:p xmlns:a="http://schemas.openxmlformats.org/drawingml/2006/main">
             <a:pPr algn="ctr">
+              <a:buNone/>
               <a:defRPr sz="1125" b="0">
                 <a:solidFill>
                   <a:srgbClr val="536273"/>
@@ -10477,7 +10586,7 @@
                 <a:ea typeface="Arial"/>
                 <a:cs typeface="Arial"/>
               </a:rPr>
-              <a:t>Fuera del margen: ruta real más cercana</a:t>
+              <a:t>Si ninguna candidata cumple ±20 %, se entrega la ruta real más cercana sin llamarla optimizada por distancia.</a:t>
             </a:r>
           </a:p>
         </p:txBody>
@@ -10512,11 +10621,12 @@
         </p:spPr>
         <p:txBody>
           <a:bodyPr xmlns:a="http://schemas.openxmlformats.org/drawingml/2006/main" lIns="0" tIns="0" rIns="0" bIns="0" anchor="t">
-            <a:normAutofit fontScale="100000"/>
+            <a:normAutofit fontScale="95238"/>
           </a:bodyPr>
           <a:lstStyle xmlns:a="http://schemas.openxmlformats.org/drawingml/2006/main"/>
           <a:p xmlns:a="http://schemas.openxmlformats.org/drawingml/2006/main">
             <a:pPr algn="ctr">
+              <a:buNone/>
               <a:defRPr sz="1575" b="0">
                 <a:solidFill>
                   <a:srgbClr val="536273"/>
@@ -10535,7 +10645,7 @@
                 <a:ea typeface="Arial"/>
                 <a:cs typeface="Arial"/>
               </a:rPr>
-              <a:t>Si ninguna llamada devuelve una ruta real, se muestra un error controlado. No se devuelve un resultado ficticio.</a:t>
+              <a:t>Si ORS no obtiene un circuito, se prueban hasta tres destinos deterministas y se unen dos trayectos reales: ida y regreso. El resultado se identifica como ida y vuelta y no se presenta como optimizado por viento.</a:t>
             </a:r>
           </a:p>
         </p:txBody>
@@ -10597,6 +10707,7 @@
           <a:lstStyle xmlns:a="http://schemas.openxmlformats.org/drawingml/2006/main"/>
           <a:p xmlns:a="http://schemas.openxmlformats.org/drawingml/2006/main">
             <a:pPr algn="l">
+              <a:buNone/>
               <a:defRPr sz="1050" b="1">
                 <a:solidFill>
                   <a:srgbClr val="3D8DFF"/>
@@ -10655,6 +10766,7 @@
           <a:lstStyle xmlns:a="http://schemas.openxmlformats.org/drawingml/2006/main"/>
           <a:p xmlns:a="http://schemas.openxmlformats.org/drawingml/2006/main">
             <a:pPr algn="l">
+              <a:buNone/>
               <a:defRPr sz="2850" b="1">
                 <a:solidFill>
                   <a:srgbClr val="0B1B2B"/>
@@ -10775,6 +10887,7 @@
           <a:lstStyle xmlns:a="http://schemas.openxmlformats.org/drawingml/2006/main"/>
           <a:p xmlns:a="http://schemas.openxmlformats.org/drawingml/2006/main">
             <a:pPr algn="l">
+              <a:buNone/>
               <a:defRPr sz="975" b="0">
                 <a:solidFill>
                   <a:srgbClr val="536273"/>
@@ -10833,6 +10946,7 @@
           <a:lstStyle xmlns:a="http://schemas.openxmlformats.org/drawingml/2006/main"/>
           <a:p xmlns:a="http://schemas.openxmlformats.org/drawingml/2006/main">
             <a:pPr algn="r">
+              <a:buNone/>
               <a:defRPr sz="975" b="0">
                 <a:solidFill>
                   <a:srgbClr val="536273"/>
@@ -11019,6 +11133,7 @@
           <a:lstStyle xmlns:a="http://schemas.openxmlformats.org/drawingml/2006/main"/>
           <a:p xmlns:a="http://schemas.openxmlformats.org/drawingml/2006/main">
             <a:pPr algn="l">
+              <a:buNone/>
               <a:defRPr sz="1800" b="1">
                 <a:solidFill>
                   <a:srgbClr val="0B1B2B"/>
@@ -11077,6 +11192,7 @@
           <a:lstStyle xmlns:a="http://schemas.openxmlformats.org/drawingml/2006/main"/>
           <a:p xmlns:a="http://schemas.openxmlformats.org/drawingml/2006/main">
             <a:pPr algn="l">
+              <a:buNone/>
               <a:defRPr sz="1275" b="0">
                 <a:solidFill>
                   <a:srgbClr val="536273"/>
@@ -11170,6 +11286,7 @@
           <a:lstStyle xmlns:a="http://schemas.openxmlformats.org/drawingml/2006/main"/>
           <a:p xmlns:a="http://schemas.openxmlformats.org/drawingml/2006/main">
             <a:pPr algn="l">
+              <a:buNone/>
               <a:defRPr sz="1800" b="1">
                 <a:solidFill>
                   <a:srgbClr val="0B1B2B"/>
@@ -11228,6 +11345,7 @@
           <a:lstStyle xmlns:a="http://schemas.openxmlformats.org/drawingml/2006/main"/>
           <a:p xmlns:a="http://schemas.openxmlformats.org/drawingml/2006/main">
             <a:pPr algn="l">
+              <a:buNone/>
               <a:defRPr sz="1275" b="0">
                 <a:solidFill>
                   <a:srgbClr val="536273"/>
@@ -11321,6 +11439,7 @@
           <a:lstStyle xmlns:a="http://schemas.openxmlformats.org/drawingml/2006/main"/>
           <a:p xmlns:a="http://schemas.openxmlformats.org/drawingml/2006/main">
             <a:pPr algn="l">
+              <a:buNone/>
               <a:defRPr sz="1800" b="1">
                 <a:solidFill>
                   <a:srgbClr val="0B1B2B"/>
@@ -11379,6 +11498,7 @@
           <a:lstStyle xmlns:a="http://schemas.openxmlformats.org/drawingml/2006/main"/>
           <a:p xmlns:a="http://schemas.openxmlformats.org/drawingml/2006/main">
             <a:pPr algn="l">
+              <a:buNone/>
               <a:defRPr sz="1275" b="0">
                 <a:solidFill>
                   <a:srgbClr val="536273"/>
@@ -11472,6 +11592,7 @@
           <a:lstStyle xmlns:a="http://schemas.openxmlformats.org/drawingml/2006/main"/>
           <a:p xmlns:a="http://schemas.openxmlformats.org/drawingml/2006/main">
             <a:pPr algn="l">
+              <a:buNone/>
               <a:defRPr sz="1800" b="1">
                 <a:solidFill>
                   <a:srgbClr val="0B1B2B"/>
@@ -11530,6 +11651,7 @@
           <a:lstStyle xmlns:a="http://schemas.openxmlformats.org/drawingml/2006/main"/>
           <a:p xmlns:a="http://schemas.openxmlformats.org/drawingml/2006/main">
             <a:pPr algn="l">
+              <a:buNone/>
               <a:defRPr sz="1275" b="0">
                 <a:solidFill>
                   <a:srgbClr val="536273"/>
@@ -11588,6 +11710,7 @@
           <a:lstStyle xmlns:a="http://schemas.openxmlformats.org/drawingml/2006/main"/>
           <a:p xmlns:a="http://schemas.openxmlformats.org/drawingml/2006/main">
             <a:pPr algn="ctr">
+              <a:buNone/>
               <a:defRPr sz="1500" b="1">
                 <a:solidFill>
                   <a:srgbClr val="0B1B2B"/>
@@ -11668,6 +11791,7 @@
           <a:lstStyle xmlns:a="http://schemas.openxmlformats.org/drawingml/2006/main"/>
           <a:p xmlns:a="http://schemas.openxmlformats.org/drawingml/2006/main">
             <a:pPr algn="l">
+              <a:buNone/>
               <a:defRPr sz="1050" b="1">
                 <a:solidFill>
                   <a:srgbClr val="3D8DFF"/>
@@ -11726,6 +11850,7 @@
           <a:lstStyle xmlns:a="http://schemas.openxmlformats.org/drawingml/2006/main"/>
           <a:p xmlns:a="http://schemas.openxmlformats.org/drawingml/2006/main">
             <a:pPr algn="l">
+              <a:buNone/>
               <a:defRPr sz="2850" b="1">
                 <a:solidFill>
                   <a:srgbClr val="0B1B2B"/>
@@ -11846,6 +11971,7 @@
           <a:lstStyle xmlns:a="http://schemas.openxmlformats.org/drawingml/2006/main"/>
           <a:p xmlns:a="http://schemas.openxmlformats.org/drawingml/2006/main">
             <a:pPr algn="l">
+              <a:buNone/>
               <a:defRPr sz="975" b="0">
                 <a:solidFill>
                   <a:srgbClr val="536273"/>
@@ -11904,6 +12030,7 @@
           <a:lstStyle xmlns:a="http://schemas.openxmlformats.org/drawingml/2006/main"/>
           <a:p xmlns:a="http://schemas.openxmlformats.org/drawingml/2006/main">
             <a:pPr algn="r">
+              <a:buNone/>
               <a:defRPr sz="975" b="0">
                 <a:solidFill>
                   <a:srgbClr val="536273"/>
@@ -12028,6 +12155,7 @@
           <a:lstStyle xmlns:a="http://schemas.openxmlformats.org/drawingml/2006/main"/>
           <a:p xmlns:a="http://schemas.openxmlformats.org/drawingml/2006/main">
             <a:pPr algn="l">
+              <a:buNone/>
               <a:defRPr sz="1800" b="1">
                 <a:solidFill>
                   <a:srgbClr val="0B1B2B"/>
@@ -12086,6 +12214,7 @@
           <a:lstStyle xmlns:a="http://schemas.openxmlformats.org/drawingml/2006/main"/>
           <a:p xmlns:a="http://schemas.openxmlformats.org/drawingml/2006/main">
             <a:pPr algn="l">
+              <a:buNone/>
               <a:defRPr sz="1350" b="0">
                 <a:solidFill>
                   <a:srgbClr val="536273"/>
@@ -12104,7 +12233,7 @@
                 <a:ea typeface="Arial"/>
                 <a:cs typeface="Arial"/>
               </a:rPr>
-              <a:t>La contraseña temporal se genera en backend, se envía por correo y solo se persiste passwordHash. Nunca vuelve por HTTP.</a:t>
+              <a:t>La contraseña temporal se genera en backend, se envía mediante Gmail SMTP y solo se persiste passwordHash. Nunca vuelve por HTTP.</a:t>
             </a:r>
           </a:p>
         </p:txBody>
@@ -12210,6 +12339,7 @@
           <a:lstStyle xmlns:a="http://schemas.openxmlformats.org/drawingml/2006/main"/>
           <a:p xmlns:a="http://schemas.openxmlformats.org/drawingml/2006/main">
             <a:pPr algn="l">
+              <a:buNone/>
               <a:defRPr sz="1800" b="1">
                 <a:solidFill>
                   <a:srgbClr val="0B1B2B"/>
@@ -12268,6 +12398,7 @@
           <a:lstStyle xmlns:a="http://schemas.openxmlformats.org/drawingml/2006/main"/>
           <a:p xmlns:a="http://schemas.openxmlformats.org/drawingml/2006/main">
             <a:pPr algn="l">
+              <a:buNone/>
               <a:defRPr sz="1350" b="0">
                 <a:solidFill>
                   <a:srgbClr val="536273"/>
@@ -12392,6 +12523,7 @@
           <a:lstStyle xmlns:a="http://schemas.openxmlformats.org/drawingml/2006/main"/>
           <a:p xmlns:a="http://schemas.openxmlformats.org/drawingml/2006/main">
             <a:pPr algn="l">
+              <a:buNone/>
               <a:defRPr sz="1800" b="1">
                 <a:solidFill>
                   <a:srgbClr val="0B1B2B"/>
@@ -12450,6 +12582,7 @@
           <a:lstStyle xmlns:a="http://schemas.openxmlformats.org/drawingml/2006/main"/>
           <a:p xmlns:a="http://schemas.openxmlformats.org/drawingml/2006/main">
             <a:pPr algn="l">
+              <a:buNone/>
               <a:defRPr sz="1350" b="0">
                 <a:solidFill>
                   <a:srgbClr val="536273"/>
@@ -12508,6 +12641,7 @@
           <a:lstStyle xmlns:a="http://schemas.openxmlformats.org/drawingml/2006/main"/>
           <a:p xmlns:a="http://schemas.openxmlformats.org/drawingml/2006/main">
             <a:pPr algn="ctr">
+              <a:buNone/>
               <a:defRPr sz="1575" b="1">
                 <a:solidFill>
                   <a:srgbClr val="0B1B2B"/>

</xml_diff>

<commit_message>
docs: add project origin to TFM presentation
</commit_message>
<xml_diff>
--- a/outputs/CicloViento-presentacion-proyecto.pptx
+++ b/outputs/CicloViento-presentacion-proyecto.pptx
@@ -2,24 +2,24 @@
 <file path=ppt/presentation.xml><?xml version="1.0" encoding="utf-8"?>
 <p:presentation xmlns:p="http://schemas.openxmlformats.org/presentationml/2006/main">
   <p:sldMasterIdLst>
-    <p:sldMasterId xmlns:r="http://schemas.openxmlformats.org/officeDocument/2006/relationships" id="2147483648" r:id="R45f52962ad3d4b3d"/>
+    <p:sldMasterId xmlns:r="http://schemas.openxmlformats.org/officeDocument/2006/relationships" id="2147483648" r:id="R2f29ef4e5f8a4d02"/>
   </p:sldMasterIdLst>
   <p:notesMasterIdLst>
-    <p:notesMasterId xmlns:r="http://schemas.openxmlformats.org/officeDocument/2006/relationships" r:id="R788fc4caaec94070"/>
+    <p:notesMasterId xmlns:r="http://schemas.openxmlformats.org/officeDocument/2006/relationships" r:id="R4363234678e54f01"/>
   </p:notesMasterIdLst>
   <p:sldIdLst>
-    <p:sldId xmlns:r="http://schemas.openxmlformats.org/officeDocument/2006/relationships" id="256" r:id="R88789e28293d46b5"/>
-    <p:sldId xmlns:r="http://schemas.openxmlformats.org/officeDocument/2006/relationships" id="257" r:id="R72380b0fe3ff45de"/>
-    <p:sldId xmlns:r="http://schemas.openxmlformats.org/officeDocument/2006/relationships" id="258" r:id="R41485bc7c5214b5b"/>
-    <p:sldId xmlns:r="http://schemas.openxmlformats.org/officeDocument/2006/relationships" id="259" r:id="R3684c5112eeb4d6c"/>
-    <p:sldId xmlns:r="http://schemas.openxmlformats.org/officeDocument/2006/relationships" id="260" r:id="R2216ca6a7dfb404e"/>
-    <p:sldId xmlns:r="http://schemas.openxmlformats.org/officeDocument/2006/relationships" id="261" r:id="Rf62e33620df1430e"/>
-    <p:sldId xmlns:r="http://schemas.openxmlformats.org/officeDocument/2006/relationships" id="262" r:id="Re036a762bfc24b57"/>
-    <p:sldId xmlns:r="http://schemas.openxmlformats.org/officeDocument/2006/relationships" id="263" r:id="R1721c40903274b76"/>
-    <p:sldId xmlns:r="http://schemas.openxmlformats.org/officeDocument/2006/relationships" id="264" r:id="Rbd964b45bde54b9f"/>
-    <p:sldId xmlns:r="http://schemas.openxmlformats.org/officeDocument/2006/relationships" id="265" r:id="R7d17bfa19be247d7"/>
-    <p:sldId xmlns:r="http://schemas.openxmlformats.org/officeDocument/2006/relationships" id="266" r:id="R1db8f10db8454488"/>
-    <p:sldId xmlns:r="http://schemas.openxmlformats.org/officeDocument/2006/relationships" id="267" r:id="R7a02ee6bd64e4834"/>
+    <p:sldId xmlns:r="http://schemas.openxmlformats.org/officeDocument/2006/relationships" id="256" r:id="R9a3faca9c2434c7e"/>
+    <p:sldId xmlns:r="http://schemas.openxmlformats.org/officeDocument/2006/relationships" id="257" r:id="R532664fbce8943b3"/>
+    <p:sldId xmlns:r="http://schemas.openxmlformats.org/officeDocument/2006/relationships" id="258" r:id="R8704aa33bd0046e8"/>
+    <p:sldId xmlns:r="http://schemas.openxmlformats.org/officeDocument/2006/relationships" id="259" r:id="R27c9632b27494bf1"/>
+    <p:sldId xmlns:r="http://schemas.openxmlformats.org/officeDocument/2006/relationships" id="260" r:id="R1ba5e4b2922c4960"/>
+    <p:sldId xmlns:r="http://schemas.openxmlformats.org/officeDocument/2006/relationships" id="261" r:id="R02d3d617568f4867"/>
+    <p:sldId xmlns:r="http://schemas.openxmlformats.org/officeDocument/2006/relationships" id="262" r:id="Rf546efa159324585"/>
+    <p:sldId xmlns:r="http://schemas.openxmlformats.org/officeDocument/2006/relationships" id="263" r:id="R4d44719b37e8443d"/>
+    <p:sldId xmlns:r="http://schemas.openxmlformats.org/officeDocument/2006/relationships" id="264" r:id="Rd7c31361580d4b79"/>
+    <p:sldId xmlns:r="http://schemas.openxmlformats.org/officeDocument/2006/relationships" id="265" r:id="R5ce7ec8b58e3451c"/>
+    <p:sldId xmlns:r="http://schemas.openxmlformats.org/officeDocument/2006/relationships" id="266" r:id="Raf0a613d83e14aa8"/>
+    <p:sldId xmlns:r="http://schemas.openxmlformats.org/officeDocument/2006/relationships" id="267" r:id="R101bb50a2491432c"/>
   </p:sldIdLst>
   <p:sldSz cx="12192000" cy="6858000"/>
   <p:notesSz cx="6858000" cy="9144000"/>
@@ -1243,7 +1243,7 @@
   </p:cSld>
   <p:clrMap bg1="lt1" tx1="dk1" bg2="lt2" tx2="dk2" accent1="accent1" accent2="accent2" accent3="accent3" accent4="accent4" accent5="accent5" accent6="accent6" hlink="hlink" folHlink="folHlink"/>
   <p:sldLayoutIdLst>
-    <p:sldLayoutId xmlns:r="http://schemas.openxmlformats.org/officeDocument/2006/relationships" id="2147483649" r:id="R9a360dce2b8b4101"/>
+    <p:sldLayoutId xmlns:r="http://schemas.openxmlformats.org/officeDocument/2006/relationships" id="2147483649" r:id="R21ce53e388a04a22"/>
   </p:sldLayoutIdLst>
   <p:txStyles>
     <p:titleStyle>
@@ -2124,7 +2124,7 @@
           <p:nvPr/>
         </p:nvPicPr>
         <p:blipFill>
-          <a:blip xmlns:r="http://schemas.openxmlformats.org/officeDocument/2006/relationships" xmlns:a="http://schemas.openxmlformats.org/drawingml/2006/main" r:embed="Rc6e64ee3da474289"/>
+          <a:blip xmlns:r="http://schemas.openxmlformats.org/officeDocument/2006/relationships" xmlns:a="http://schemas.openxmlformats.org/drawingml/2006/main" r:embed="R52cdec6d29f54a1d"/>
           <a:srcRect xmlns:a="http://schemas.openxmlformats.org/drawingml/2006/main" l="0" t="316" r="0" b="316"/>
           <a:stretch xmlns:a="http://schemas.openxmlformats.org/drawingml/2006/main">
             <a:fillRect l="0" t="0" r="0" b="0"/>
@@ -4587,7 +4587,7 @@
                 <a:ea typeface="Arial"/>
                 <a:cs typeface="Arial"/>
               </a:rPr>
-              <a:t>Planificar no es solo elegir una distancia</a:t>
+              <a:t>CicloViento nace de una necesidad en las salidas en grupo</a:t>
             </a:r>
           </a:p>
         </p:txBody>
@@ -4892,7 +4892,7 @@
                 <a:ea typeface="Arial"/>
                 <a:cs typeface="Arial"/>
               </a:rPr>
-              <a:t>Punto de partida</a:t>
+              <a:t>Rutas compartidas</a:t>
             </a:r>
           </a:p>
         </p:txBody>
@@ -4951,7 +4951,7 @@
                 <a:ea typeface="Arial"/>
                 <a:cs typeface="Arial"/>
               </a:rPr>
-              <a:t>La ruta debe comenzar desde una ubicación concreta y respetar la distancia y el desnivel solicitados.</a:t>
+              <a:t>Soy ciclista aficionado y participo en un club que organiza rutas todos los fines de semana.</a:t>
             </a:r>
           </a:p>
         </p:txBody>
@@ -5076,7 +5076,7 @@
                 <a:ea typeface="Arial"/>
                 <a:cs typeface="Arial"/>
               </a:rPr>
-              <a:t>Meteorología</a:t>
+              <a:t>Dureza conocida</a:t>
             </a:r>
           </a:p>
         </p:txBody>
@@ -5135,7 +5135,7 @@
                 <a:ea typeface="Arial"/>
                 <a:cs typeface="Arial"/>
               </a:rPr>
-              <a:t>El ciclista necesita conocer la condición general, temperatura, lluvia, velocidad y rachas de viento.</a:t>
+              <a:t>La distancia y el desnivel acumulado permiten anticipar el esfuerzo y decidir si sumarse a la salida.</a:t>
             </a:r>
           </a:p>
         </p:txBody>
@@ -5260,7 +5260,7 @@
                 <a:ea typeface="Arial"/>
                 <a:cs typeface="Arial"/>
               </a:rPr>
-              <a:t>Regreso</a:t>
+              <a:t>Viento no previsto</a:t>
             </a:r>
           </a:p>
         </p:txBody>
@@ -5319,7 +5319,7 @@
                 <a:ea typeface="Arial"/>
                 <a:cs typeface="Arial"/>
               </a:rPr>
-              <a:t>La dirección del viento puede condicionar especialmente el tramo final del recorrido.</a:t>
+              <a:t>El viento puede cambiar por completo la dureza de la jornada, pero suele quedar fuera de la planificación inicial.</a:t>
             </a:r>
           </a:p>
         </p:txBody>
@@ -5378,7 +5378,7 @@
                 <a:ea typeface="Arial"/>
                 <a:cs typeface="Arial"/>
               </a:rPr>
-              <a:t>Objetivo: informar y ayudar a decidir; no afirmar una optimización meteorológica inexistente.</a:t>
+              <a:t>CicloViento integra ruta y viento para ofrecer al grupo una previsión más realista antes de salir.</a:t>
             </a:r>
           </a:p>
         </p:txBody>

</xml_diff>